<commit_message>
Final Presentations and Video Link
</commit_message>
<xml_diff>
--- a/week-04/Capstone_1/JimBeam_10min.pptx
+++ b/week-04/Capstone_1/JimBeam_10min.pptx
@@ -13,7 +13,7 @@
     <p:sldId id="258" r:id="rId4"/>
     <p:sldId id="259" r:id="rId5"/>
     <p:sldId id="270" r:id="rId6"/>
-    <p:sldId id="260" r:id="rId7"/>
+    <p:sldId id="266" r:id="rId7"/>
     <p:sldId id="262" r:id="rId8"/>
     <p:sldId id="263" r:id="rId9"/>
     <p:sldId id="264" r:id="rId10"/>
@@ -126,13 +126,132 @@
 <file path=ppt/revisionInfo.xml><?xml version="1.0" encoding="utf-8"?>
 <p1510:revInfo xmlns:a="http://schemas.openxmlformats.org/drawingml/2006/main" xmlns:r="http://schemas.openxmlformats.org/officeDocument/2006/relationships" xmlns:p1510="http://schemas.microsoft.com/office/powerpoint/2015/10/main">
   <p1510:revLst>
+    <p1510:client id="{203C52F8-1FDA-826D-9BC2-87F496F5536A}" v="1" dt="2026-04-30T16:44:45.261"/>
+    <p1510:client id="{268BE901-C98A-A35C-79A6-52C18A20C532}" v="10" dt="2026-04-30T13:13:29.958"/>
     <p1510:client id="{B14773D7-E6A8-D03B-B021-E177D8FCE6E4}" v="153" dt="2026-04-30T04:11:13.189"/>
+    <p1510:client id="{EB5279E9-AFC0-75CB-2B70-25A30470148C}" v="149" dt="2026-04-30T16:23:03.780"/>
   </p1510:revLst>
 </p1510:revInfo>
 </file>
 
 <file path=ppt/changesInfos/changesInfo1.xml><?xml version="1.0" encoding="utf-8"?>
 <pc:chgInfo xmlns:a="http://schemas.openxmlformats.org/drawingml/2006/main" xmlns:r="http://schemas.openxmlformats.org/officeDocument/2006/relationships" xmlns:ac="http://schemas.microsoft.com/office/drawing/2013/main/command" xmlns:pc="http://schemas.microsoft.com/office/powerpoint/2013/main/command">
+  <pc:docChgLst>
+    <pc:chgData name="cagla celik" userId="S::ccelik@my.yearupunited.org::7b188b8e-7d7c-466a-bff8-d38aee0ad76d" providerId="AD" clId="Web-{268BE901-C98A-A35C-79A6-52C18A20C532}"/>
+    <pc:docChg chg="modSld modMainMaster">
+      <pc:chgData name="cagla celik" userId="S::ccelik@my.yearupunited.org::7b188b8e-7d7c-466a-bff8-d38aee0ad76d" providerId="AD" clId="Web-{268BE901-C98A-A35C-79A6-52C18A20C532}" dt="2026-04-30T13:13:29.958" v="9" actId="1076"/>
+      <pc:docMkLst>
+        <pc:docMk/>
+      </pc:docMkLst>
+      <pc:sldChg chg="modTransition">
+        <pc:chgData name="cagla celik" userId="S::ccelik@my.yearupunited.org::7b188b8e-7d7c-466a-bff8-d38aee0ad76d" providerId="AD" clId="Web-{268BE901-C98A-A35C-79A6-52C18A20C532}" dt="2026-04-30T13:12:33.880" v="6"/>
+        <pc:sldMkLst>
+          <pc:docMk/>
+          <pc:sldMk cId="0" sldId="258"/>
+        </pc:sldMkLst>
+      </pc:sldChg>
+      <pc:sldChg chg="modTransition">
+        <pc:chgData name="cagla celik" userId="S::ccelik@my.yearupunited.org::7b188b8e-7d7c-466a-bff8-d38aee0ad76d" providerId="AD" clId="Web-{268BE901-C98A-A35C-79A6-52C18A20C532}" dt="2026-04-30T13:12:33.880" v="6"/>
+        <pc:sldMkLst>
+          <pc:docMk/>
+          <pc:sldMk cId="0" sldId="259"/>
+        </pc:sldMkLst>
+      </pc:sldChg>
+      <pc:sldChg chg="modTransition">
+        <pc:chgData name="cagla celik" userId="S::ccelik@my.yearupunited.org::7b188b8e-7d7c-466a-bff8-d38aee0ad76d" providerId="AD" clId="Web-{268BE901-C98A-A35C-79A6-52C18A20C532}" dt="2026-04-30T13:12:33.880" v="6"/>
+        <pc:sldMkLst>
+          <pc:docMk/>
+          <pc:sldMk cId="0" sldId="260"/>
+        </pc:sldMkLst>
+      </pc:sldChg>
+      <pc:sldChg chg="modTransition">
+        <pc:chgData name="cagla celik" userId="S::ccelik@my.yearupunited.org::7b188b8e-7d7c-466a-bff8-d38aee0ad76d" providerId="AD" clId="Web-{268BE901-C98A-A35C-79A6-52C18A20C532}" dt="2026-04-30T13:12:33.880" v="6"/>
+        <pc:sldMkLst>
+          <pc:docMk/>
+          <pc:sldMk cId="0" sldId="262"/>
+        </pc:sldMkLst>
+      </pc:sldChg>
+      <pc:sldChg chg="modTransition">
+        <pc:chgData name="cagla celik" userId="S::ccelik@my.yearupunited.org::7b188b8e-7d7c-466a-bff8-d38aee0ad76d" providerId="AD" clId="Web-{268BE901-C98A-A35C-79A6-52C18A20C532}" dt="2026-04-30T13:12:33.880" v="6"/>
+        <pc:sldMkLst>
+          <pc:docMk/>
+          <pc:sldMk cId="0" sldId="263"/>
+        </pc:sldMkLst>
+      </pc:sldChg>
+      <pc:sldChg chg="modTransition">
+        <pc:chgData name="cagla celik" userId="S::ccelik@my.yearupunited.org::7b188b8e-7d7c-466a-bff8-d38aee0ad76d" providerId="AD" clId="Web-{268BE901-C98A-A35C-79A6-52C18A20C532}" dt="2026-04-30T13:12:33.880" v="6"/>
+        <pc:sldMkLst>
+          <pc:docMk/>
+          <pc:sldMk cId="0" sldId="264"/>
+        </pc:sldMkLst>
+      </pc:sldChg>
+      <pc:sldChg chg="modTransition">
+        <pc:chgData name="cagla celik" userId="S::ccelik@my.yearupunited.org::7b188b8e-7d7c-466a-bff8-d38aee0ad76d" providerId="AD" clId="Web-{268BE901-C98A-A35C-79A6-52C18A20C532}" dt="2026-04-30T13:12:33.880" v="6"/>
+        <pc:sldMkLst>
+          <pc:docMk/>
+          <pc:sldMk cId="0" sldId="265"/>
+        </pc:sldMkLst>
+      </pc:sldChg>
+      <pc:sldChg chg="modTransition">
+        <pc:chgData name="cagla celik" userId="S::ccelik@my.yearupunited.org::7b188b8e-7d7c-466a-bff8-d38aee0ad76d" providerId="AD" clId="Web-{268BE901-C98A-A35C-79A6-52C18A20C532}" dt="2026-04-30T13:12:33.880" v="6"/>
+        <pc:sldMkLst>
+          <pc:docMk/>
+          <pc:sldMk cId="0" sldId="267"/>
+        </pc:sldMkLst>
+      </pc:sldChg>
+      <pc:sldChg chg="modTransition">
+        <pc:chgData name="cagla celik" userId="S::ccelik@my.yearupunited.org::7b188b8e-7d7c-466a-bff8-d38aee0ad76d" providerId="AD" clId="Web-{268BE901-C98A-A35C-79A6-52C18A20C532}" dt="2026-04-30T13:12:33.880" v="6"/>
+        <pc:sldMkLst>
+          <pc:docMk/>
+          <pc:sldMk cId="1104918865" sldId="268"/>
+        </pc:sldMkLst>
+      </pc:sldChg>
+      <pc:sldChg chg="modTransition">
+        <pc:chgData name="cagla celik" userId="S::ccelik@my.yearupunited.org::7b188b8e-7d7c-466a-bff8-d38aee0ad76d" providerId="AD" clId="Web-{268BE901-C98A-A35C-79A6-52C18A20C532}" dt="2026-04-30T13:12:33.880" v="6"/>
+        <pc:sldMkLst>
+          <pc:docMk/>
+          <pc:sldMk cId="3401373035" sldId="269"/>
+        </pc:sldMkLst>
+      </pc:sldChg>
+      <pc:sldChg chg="modSp modTransition">
+        <pc:chgData name="cagla celik" userId="S::ccelik@my.yearupunited.org::7b188b8e-7d7c-466a-bff8-d38aee0ad76d" providerId="AD" clId="Web-{268BE901-C98A-A35C-79A6-52C18A20C532}" dt="2026-04-30T13:13:29.958" v="9" actId="1076"/>
+        <pc:sldMkLst>
+          <pc:docMk/>
+          <pc:sldMk cId="631828014" sldId="270"/>
+        </pc:sldMkLst>
+        <pc:picChg chg="mod modCrop">
+          <ac:chgData name="cagla celik" userId="S::ccelik@my.yearupunited.org::7b188b8e-7d7c-466a-bff8-d38aee0ad76d" providerId="AD" clId="Web-{268BE901-C98A-A35C-79A6-52C18A20C532}" dt="2026-04-30T13:13:29.958" v="9" actId="1076"/>
+          <ac:picMkLst>
+            <pc:docMk/>
+            <pc:sldMk cId="631828014" sldId="270"/>
+            <ac:picMk id="5" creationId="{00000000-0000-0000-0000-000000000000}"/>
+          </ac:picMkLst>
+        </pc:picChg>
+      </pc:sldChg>
+      <pc:sldChg chg="modTransition">
+        <pc:chgData name="cagla celik" userId="S::ccelik@my.yearupunited.org::7b188b8e-7d7c-466a-bff8-d38aee0ad76d" providerId="AD" clId="Web-{268BE901-C98A-A35C-79A6-52C18A20C532}" dt="2026-04-30T13:12:33.880" v="6"/>
+        <pc:sldMkLst>
+          <pc:docMk/>
+          <pc:sldMk cId="1233154207" sldId="271"/>
+        </pc:sldMkLst>
+      </pc:sldChg>
+      <pc:sldMasterChg chg="modTransition modSldLayout">
+        <pc:chgData name="cagla celik" userId="S::ccelik@my.yearupunited.org::7b188b8e-7d7c-466a-bff8-d38aee0ad76d" providerId="AD" clId="Web-{268BE901-C98A-A35C-79A6-52C18A20C532}" dt="2026-04-30T13:12:33.880" v="6"/>
+        <pc:sldMasterMkLst>
+          <pc:docMk/>
+          <pc:sldMasterMk cId="0" sldId="2147483648"/>
+        </pc:sldMasterMkLst>
+        <pc:sldLayoutChg chg="modTransition">
+          <pc:chgData name="cagla celik" userId="S::ccelik@my.yearupunited.org::7b188b8e-7d7c-466a-bff8-d38aee0ad76d" providerId="AD" clId="Web-{268BE901-C98A-A35C-79A6-52C18A20C532}" dt="2026-04-30T13:12:33.880" v="6"/>
+          <pc:sldLayoutMkLst>
+            <pc:docMk/>
+            <pc:sldMasterMk cId="0" sldId="2147483648"/>
+            <pc:sldLayoutMk cId="0" sldId="2147483649"/>
+          </pc:sldLayoutMkLst>
+        </pc:sldLayoutChg>
+      </pc:sldMasterChg>
+    </pc:docChg>
+  </pc:docChgLst>
   <pc:docChgLst>
     <pc:chgData name="cagla celik" userId="S::ccelik@my.yearupunited.org::7b188b8e-7d7c-466a-bff8-d38aee0ad76d" providerId="AD" clId="Web-{B14773D7-E6A8-D03B-B021-E177D8FCE6E4}"/>
     <pc:docChg chg="addSld delSld modSld">
@@ -518,13 +637,13 @@
         <pc:chgData name="cagla celik" userId="S::ccelik@my.yearupunited.org::7b188b8e-7d7c-466a-bff8-d38aee0ad76d" providerId="AD" clId="Web-{B14773D7-E6A8-D03B-B021-E177D8FCE6E4}" dt="2026-04-30T04:07:08.162" v="130"/>
         <pc:sldMkLst>
           <pc:docMk/>
-          <pc:sldMk cId="0" sldId="266"/>
+          <pc:sldMk cId="1325269250" sldId="266"/>
         </pc:sldMkLst>
         <pc:spChg chg="mod">
           <ac:chgData name="cagla celik" userId="S::ccelik@my.yearupunited.org::7b188b8e-7d7c-466a-bff8-d38aee0ad76d" providerId="AD" clId="Web-{B14773D7-E6A8-D03B-B021-E177D8FCE6E4}" dt="2026-04-30T02:22:44.721" v="57" actId="20577"/>
           <ac:spMkLst>
             <pc:docMk/>
-            <pc:sldMk cId="0" sldId="266"/>
+            <pc:sldMk cId="1325269250" sldId="266"/>
             <ac:spMk id="10" creationId="{00000000-0000-0000-0000-000000000000}"/>
           </ac:spMkLst>
         </pc:spChg>
@@ -598,6 +717,140 @@
       </pc:sldChg>
     </pc:docChg>
   </pc:docChgLst>
+  <pc:docChgLst>
+    <pc:chgData name="cagla celik" userId="S::ccelik@my.yearupunited.org::7b188b8e-7d7c-466a-bff8-d38aee0ad76d" providerId="AD" clId="Web-{203C52F8-1FDA-826D-9BC2-87F496F5536A}"/>
+    <pc:docChg chg="modSld">
+      <pc:chgData name="cagla celik" userId="S::ccelik@my.yearupunited.org::7b188b8e-7d7c-466a-bff8-d38aee0ad76d" providerId="AD" clId="Web-{203C52F8-1FDA-826D-9BC2-87F496F5536A}" dt="2026-04-30T16:44:45.261" v="0" actId="20577"/>
+      <pc:docMkLst>
+        <pc:docMk/>
+      </pc:docMkLst>
+      <pc:sldChg chg="modSp">
+        <pc:chgData name="cagla celik" userId="S::ccelik@my.yearupunited.org::7b188b8e-7d7c-466a-bff8-d38aee0ad76d" providerId="AD" clId="Web-{203C52F8-1FDA-826D-9BC2-87F496F5536A}" dt="2026-04-30T16:44:45.261" v="0" actId="20577"/>
+        <pc:sldMkLst>
+          <pc:docMk/>
+          <pc:sldMk cId="1325269250" sldId="266"/>
+        </pc:sldMkLst>
+        <pc:spChg chg="mod">
+          <ac:chgData name="cagla celik" userId="S::ccelik@my.yearupunited.org::7b188b8e-7d7c-466a-bff8-d38aee0ad76d" providerId="AD" clId="Web-{203C52F8-1FDA-826D-9BC2-87F496F5536A}" dt="2026-04-30T16:44:45.261" v="0" actId="20577"/>
+          <ac:spMkLst>
+            <pc:docMk/>
+            <pc:sldMk cId="1325269250" sldId="266"/>
+            <ac:spMk id="3" creationId="{00000000-0000-0000-0000-000000000000}"/>
+          </ac:spMkLst>
+        </pc:spChg>
+      </pc:sldChg>
+    </pc:docChg>
+  </pc:docChgLst>
+  <pc:docChgLst>
+    <pc:chgData name="cagla celik" userId="S::ccelik@my.yearupunited.org::7b188b8e-7d7c-466a-bff8-d38aee0ad76d" providerId="AD" clId="Web-{EB5279E9-AFC0-75CB-2B70-25A30470148C}"/>
+    <pc:docChg chg="addSld delSld modSld">
+      <pc:chgData name="cagla celik" userId="S::ccelik@my.yearupunited.org::7b188b8e-7d7c-466a-bff8-d38aee0ad76d" providerId="AD" clId="Web-{EB5279E9-AFC0-75CB-2B70-25A30470148C}" dt="2026-04-30T16:23:03.780" v="144" actId="1076"/>
+      <pc:docMkLst>
+        <pc:docMk/>
+      </pc:docMkLst>
+      <pc:sldChg chg="addSp delSp modSp del">
+        <pc:chgData name="cagla celik" userId="S::ccelik@my.yearupunited.org::7b188b8e-7d7c-466a-bff8-d38aee0ad76d" providerId="AD" clId="Web-{EB5279E9-AFC0-75CB-2B70-25A30470148C}" dt="2026-04-30T16:15:42.265" v="15"/>
+        <pc:sldMkLst>
+          <pc:docMk/>
+          <pc:sldMk cId="0" sldId="260"/>
+        </pc:sldMkLst>
+        <pc:spChg chg="mod">
+          <ac:chgData name="cagla celik" userId="S::ccelik@my.yearupunited.org::7b188b8e-7d7c-466a-bff8-d38aee0ad76d" providerId="AD" clId="Web-{EB5279E9-AFC0-75CB-2B70-25A30470148C}" dt="2026-04-30T16:09:30.922" v="1" actId="20577"/>
+          <ac:spMkLst>
+            <pc:docMk/>
+            <pc:sldMk cId="0" sldId="260"/>
+            <ac:spMk id="4" creationId="{00000000-0000-0000-0000-000000000000}"/>
+          </ac:spMkLst>
+        </pc:spChg>
+        <pc:spChg chg="del">
+          <ac:chgData name="cagla celik" userId="S::ccelik@my.yearupunited.org::7b188b8e-7d7c-466a-bff8-d38aee0ad76d" providerId="AD" clId="Web-{EB5279E9-AFC0-75CB-2B70-25A30470148C}" dt="2026-04-30T16:09:37.985" v="2"/>
+          <ac:spMkLst>
+            <pc:docMk/>
+            <pc:sldMk cId="0" sldId="260"/>
+            <ac:spMk id="6" creationId="{C3A6E355-A581-67BB-272A-64318AA8903F}"/>
+          </ac:spMkLst>
+        </pc:spChg>
+        <pc:picChg chg="del">
+          <ac:chgData name="cagla celik" userId="S::ccelik@my.yearupunited.org::7b188b8e-7d7c-466a-bff8-d38aee0ad76d" providerId="AD" clId="Web-{EB5279E9-AFC0-75CB-2B70-25A30470148C}" dt="2026-04-30T16:09:24.141" v="0"/>
+          <ac:picMkLst>
+            <pc:docMk/>
+            <pc:sldMk cId="0" sldId="260"/>
+            <ac:picMk id="5" creationId="{00000000-0000-0000-0000-000000000000}"/>
+          </ac:picMkLst>
+        </pc:picChg>
+        <pc:picChg chg="add del mod">
+          <ac:chgData name="cagla celik" userId="S::ccelik@my.yearupunited.org::7b188b8e-7d7c-466a-bff8-d38aee0ad76d" providerId="AD" clId="Web-{EB5279E9-AFC0-75CB-2B70-25A30470148C}" dt="2026-04-30T16:09:54.266" v="4"/>
+          <ac:picMkLst>
+            <pc:docMk/>
+            <pc:sldMk cId="0" sldId="260"/>
+            <ac:picMk id="9" creationId="{C617E0F3-3BD3-593E-C755-88AD49BD0046}"/>
+          </ac:picMkLst>
+        </pc:picChg>
+        <pc:picChg chg="add mod">
+          <ac:chgData name="cagla celik" userId="S::ccelik@my.yearupunited.org::7b188b8e-7d7c-466a-bff8-d38aee0ad76d" providerId="AD" clId="Web-{EB5279E9-AFC0-75CB-2B70-25A30470148C}" dt="2026-04-30T16:14:14.625" v="13"/>
+          <ac:picMkLst>
+            <pc:docMk/>
+            <pc:sldMk cId="0" sldId="260"/>
+            <ac:picMk id="10" creationId="{2D8CDE5B-139F-3A8C-5FCB-C8C2DFB93370}"/>
+          </ac:picMkLst>
+        </pc:picChg>
+      </pc:sldChg>
+      <pc:sldChg chg="addSp delSp modSp">
+        <pc:chgData name="cagla celik" userId="S::ccelik@my.yearupunited.org::7b188b8e-7d7c-466a-bff8-d38aee0ad76d" providerId="AD" clId="Web-{EB5279E9-AFC0-75CB-2B70-25A30470148C}" dt="2026-04-30T16:23:03.780" v="144" actId="1076"/>
+        <pc:sldMkLst>
+          <pc:docMk/>
+          <pc:sldMk cId="0" sldId="262"/>
+        </pc:sldMkLst>
+        <pc:spChg chg="mod">
+          <ac:chgData name="cagla celik" userId="S::ccelik@my.yearupunited.org::7b188b8e-7d7c-466a-bff8-d38aee0ad76d" providerId="AD" clId="Web-{EB5279E9-AFC0-75CB-2B70-25A30470148C}" dt="2026-04-30T16:16:46.156" v="59" actId="20577"/>
+          <ac:spMkLst>
+            <pc:docMk/>
+            <pc:sldMk cId="0" sldId="262"/>
+            <ac:spMk id="3" creationId="{00000000-0000-0000-0000-000000000000}"/>
+          </ac:spMkLst>
+        </pc:spChg>
+        <pc:spChg chg="mod">
+          <ac:chgData name="cagla celik" userId="S::ccelik@my.yearupunited.org::7b188b8e-7d7c-466a-bff8-d38aee0ad76d" providerId="AD" clId="Web-{EB5279E9-AFC0-75CB-2B70-25A30470148C}" dt="2026-04-30T16:20:26.093" v="134" actId="1076"/>
+          <ac:spMkLst>
+            <pc:docMk/>
+            <pc:sldMk cId="0" sldId="262"/>
+            <ac:spMk id="4" creationId="{00000000-0000-0000-0000-000000000000}"/>
+          </ac:spMkLst>
+        </pc:spChg>
+        <pc:picChg chg="del">
+          <ac:chgData name="cagla celik" userId="S::ccelik@my.yearupunited.org::7b188b8e-7d7c-466a-bff8-d38aee0ad76d" providerId="AD" clId="Web-{EB5279E9-AFC0-75CB-2B70-25A30470148C}" dt="2026-04-30T16:15:47.734" v="16"/>
+          <ac:picMkLst>
+            <pc:docMk/>
+            <pc:sldMk cId="0" sldId="262"/>
+            <ac:picMk id="5" creationId="{00000000-0000-0000-0000-000000000000}"/>
+          </ac:picMkLst>
+        </pc:picChg>
+        <pc:picChg chg="add del mod">
+          <ac:chgData name="cagla celik" userId="S::ccelik@my.yearupunited.org::7b188b8e-7d7c-466a-bff8-d38aee0ad76d" providerId="AD" clId="Web-{EB5279E9-AFC0-75CB-2B70-25A30470148C}" dt="2026-04-30T16:22:42.124" v="139"/>
+          <ac:picMkLst>
+            <pc:docMk/>
+            <pc:sldMk cId="0" sldId="262"/>
+            <ac:picMk id="6" creationId="{2F004399-E741-8278-9380-C953904411CC}"/>
+          </ac:picMkLst>
+        </pc:picChg>
+        <pc:picChg chg="add mod">
+          <ac:chgData name="cagla celik" userId="S::ccelik@my.yearupunited.org::7b188b8e-7d7c-466a-bff8-d38aee0ad76d" providerId="AD" clId="Web-{EB5279E9-AFC0-75CB-2B70-25A30470148C}" dt="2026-04-30T16:23:03.780" v="144" actId="1076"/>
+          <ac:picMkLst>
+            <pc:docMk/>
+            <pc:sldMk cId="0" sldId="262"/>
+            <ac:picMk id="7" creationId="{3E305FB7-C8BE-BC8F-2D81-724F50C27F83}"/>
+          </ac:picMkLst>
+        </pc:picChg>
+      </pc:sldChg>
+      <pc:sldChg chg="add">
+        <pc:chgData name="cagla celik" userId="S::ccelik@my.yearupunited.org::7b188b8e-7d7c-466a-bff8-d38aee0ad76d" providerId="AD" clId="Web-{EB5279E9-AFC0-75CB-2B70-25A30470148C}" dt="2026-04-30T16:15:38.984" v="14"/>
+        <pc:sldMkLst>
+          <pc:docMk/>
+          <pc:sldMk cId="1325269250" sldId="266"/>
+        </pc:sldMkLst>
+      </pc:sldChg>
+    </pc:docChg>
+  </pc:docChgLst>
 </pc:chgInfo>
 </file>
 
@@ -682,7 +935,7 @@
           </a:lstStyle>
           <a:p>
             <a:fld id="{952354CF-E9B8-4197-9073-F6E8304C2E09}" type="datetimeFigureOut">
-              <a:t>4/29/2026</a:t>
+              <a:t>4/30/2026</a:t>
             </a:fld>
             <a:endParaRPr lang="en-US"/>
           </a:p>
@@ -1186,7 +1439,7 @@
           <a:p>
             <a:fld id="{F7021451-1387-4CA6-816F-3879F97B5CBC}" type="slidenum">
               <a:rPr lang="en-US"/>
-              <a:t>12</a:t>
+              <a:t>11</a:t>
             </a:fld>
             <a:endParaRPr lang="en-US"/>
           </a:p>
@@ -1690,7 +1943,7 @@
           <a:p>
             <a:fld id="{F7021451-1387-4CA6-816F-3879F97B5CBC}" type="slidenum">
               <a:rPr lang="en-US"/>
-              <a:t>7</a:t>
+              <a:t>6</a:t>
             </a:fld>
             <a:endParaRPr lang="en-US"/>
           </a:p>
@@ -1988,6 +2241,18 @@
   <p:clrMapOvr>
     <a:masterClrMapping/>
   </p:clrMapOvr>
+  <mc:AlternateContent xmlns:mc="http://schemas.openxmlformats.org/markup-compatibility/2006" xmlns:p14="http://schemas.microsoft.com/office/powerpoint/2010/main">
+    <mc:Choice Requires="p14">
+      <p:transition spd="slow" p14:dur="1250">
+        <p14:switch dir="r"/>
+      </p:transition>
+    </mc:Choice>
+    <mc:Fallback xmlns="">
+      <p:transition spd="slow">
+        <p:fade/>
+      </p:transition>
+    </mc:Fallback>
+  </mc:AlternateContent>
 </p:sldLayout>
 </file>
 
@@ -2019,6 +2284,18 @@
   <p:sldLayoutIdLst>
     <p:sldLayoutId id="2147483649" r:id="rId1"/>
   </p:sldLayoutIdLst>
+  <mc:AlternateContent xmlns:mc="http://schemas.openxmlformats.org/markup-compatibility/2006" xmlns:p14="http://schemas.microsoft.com/office/powerpoint/2010/main">
+    <mc:Choice Requires="p14">
+      <p:transition spd="slow" p14:dur="1250">
+        <p14:switch dir="r"/>
+      </p:transition>
+    </mc:Choice>
+    <mc:Fallback xmlns="">
+      <p:transition spd="slow">
+        <p:fade/>
+      </p:transition>
+    </mc:Fallback>
+  </mc:AlternateContent>
   <p:hf sldNum="0" hdr="0" ftr="0" dt="0"/>
   <p:txStyles>
     <p:titleStyle>
@@ -2655,6 +2932,18 @@
   <p:clrMapOvr>
     <a:masterClrMapping/>
   </p:clrMapOvr>
+  <mc:AlternateContent xmlns:mc="http://schemas.openxmlformats.org/markup-compatibility/2006" xmlns:p14="http://schemas.microsoft.com/office/powerpoint/2010/main">
+    <mc:Choice Requires="p14">
+      <p:transition spd="slow" p14:dur="1250">
+        <p14:switch dir="r"/>
+      </p:transition>
+    </mc:Choice>
+    <mc:Fallback xmlns="">
+      <p:transition spd="slow">
+        <p:fade/>
+      </p:transition>
+    </mc:Fallback>
+  </mc:AlternateContent>
 </p:sld>
 </file>
 
@@ -2813,6 +3102,18 @@
   <p:clrMapOvr>
     <a:masterClrMapping/>
   </p:clrMapOvr>
+  <mc:AlternateContent xmlns:mc="http://schemas.openxmlformats.org/markup-compatibility/2006" xmlns:p14="http://schemas.microsoft.com/office/powerpoint/2010/main">
+    <mc:Choice Requires="p14">
+      <p:transition spd="slow" p14:dur="1250">
+        <p14:switch dir="r"/>
+      </p:transition>
+    </mc:Choice>
+    <mc:Fallback xmlns="">
+      <p:transition spd="slow">
+        <p:fade/>
+      </p:transition>
+    </mc:Fallback>
+  </mc:AlternateContent>
 </p:sld>
 </file>
 
@@ -3265,6 +3566,18 @@
   <p:clrMapOvr>
     <a:masterClrMapping/>
   </p:clrMapOvr>
+  <mc:AlternateContent xmlns:mc="http://schemas.openxmlformats.org/markup-compatibility/2006" xmlns:p14="http://schemas.microsoft.com/office/powerpoint/2010/main">
+    <mc:Choice Requires="p14">
+      <p:transition spd="slow" p14:dur="1250">
+        <p14:switch dir="r"/>
+      </p:transition>
+    </mc:Choice>
+    <mc:Fallback xmlns="">
+      <p:transition spd="slow">
+        <p:fade/>
+      </p:transition>
+    </mc:Fallback>
+  </mc:AlternateContent>
 </p:sld>
 </file>
 
@@ -3824,6 +4137,18 @@
   <p:clrMapOvr>
     <a:masterClrMapping/>
   </p:clrMapOvr>
+  <mc:AlternateContent xmlns:mc="http://schemas.openxmlformats.org/markup-compatibility/2006" xmlns:p14="http://schemas.microsoft.com/office/powerpoint/2010/main">
+    <mc:Choice Requires="p14">
+      <p:transition spd="slow" p14:dur="1250">
+        <p14:switch dir="r"/>
+      </p:transition>
+    </mc:Choice>
+    <mc:Fallback xmlns="">
+      <p:transition spd="slow">
+        <p:fade/>
+      </p:transition>
+    </mc:Fallback>
+  </mc:AlternateContent>
 </p:sld>
 </file>
 
@@ -4303,6 +4628,18 @@
   <p:clrMapOvr>
     <a:masterClrMapping/>
   </p:clrMapOvr>
+  <mc:AlternateContent xmlns:mc="http://schemas.openxmlformats.org/markup-compatibility/2006" xmlns:p14="http://schemas.microsoft.com/office/powerpoint/2010/main">
+    <mc:Choice Requires="p14">
+      <p:transition spd="slow" p14:dur="1250">
+        <p14:switch dir="r"/>
+      </p:transition>
+    </mc:Choice>
+    <mc:Fallback xmlns="">
+      <p:transition spd="slow">
+        <p:fade/>
+      </p:transition>
+    </mc:Fallback>
+  </mc:AlternateContent>
 </p:sld>
 </file>
 
@@ -4922,6 +5259,18 @@
   <p:clrMapOvr>
     <a:masterClrMapping/>
   </p:clrMapOvr>
+  <mc:AlternateContent xmlns:mc="http://schemas.openxmlformats.org/markup-compatibility/2006" xmlns:p14="http://schemas.microsoft.com/office/powerpoint/2010/main">
+    <mc:Choice Requires="p14">
+      <p:transition spd="slow" p14:dur="1250">
+        <p14:switch dir="r"/>
+      </p:transition>
+    </mc:Choice>
+    <mc:Fallback xmlns="">
+      <p:transition spd="slow">
+        <p:fade/>
+      </p:transition>
+    </mc:Fallback>
+  </mc:AlternateContent>
 </p:sld>
 </file>
 
@@ -5151,6 +5500,18 @@
   <p:clrMapOvr>
     <a:masterClrMapping/>
   </p:clrMapOvr>
+  <mc:AlternateContent xmlns:mc="http://schemas.openxmlformats.org/markup-compatibility/2006" xmlns:p14="http://schemas.microsoft.com/office/powerpoint/2010/main">
+    <mc:Choice Requires="p14">
+      <p:transition spd="slow" p14:dur="1250">
+        <p14:switch dir="r"/>
+      </p:transition>
+    </mc:Choice>
+    <mc:Fallback xmlns="">
+      <p:transition spd="slow">
+        <p:fade/>
+      </p:transition>
+    </mc:Fallback>
+  </mc:AlternateContent>
 </p:sld>
 </file>
 
@@ -5286,15 +5647,15 @@
         </p:nvPicPr>
         <p:blipFill>
           <a:blip r:embed="rId3"/>
-          <a:srcRect l="262" r="262"/>
+          <a:srcRect l="261" t="5660" r="452"/>
           <a:stretch>
             <a:fillRect/>
           </a:stretch>
         </p:blipFill>
         <p:spPr>
           <a:xfrm>
-            <a:off x="274323" y="821530"/>
-            <a:ext cx="8452947" cy="4118729"/>
+            <a:off x="274323" y="938050"/>
+            <a:ext cx="8436869" cy="3885597"/>
           </a:xfrm>
           <a:prstGeom prst="rect">
             <a:avLst/>
@@ -5382,6 +5743,18 @@
   <p:clrMapOvr>
     <a:masterClrMapping/>
   </p:clrMapOvr>
+  <mc:AlternateContent xmlns:mc="http://schemas.openxmlformats.org/markup-compatibility/2006" xmlns:p14="http://schemas.microsoft.com/office/powerpoint/2010/main">
+    <mc:Choice Requires="p14">
+      <p:transition spd="slow" p14:dur="1250">
+        <p14:switch dir="r"/>
+      </p:transition>
+    </mc:Choice>
+    <mc:Fallback xmlns="">
+      <p:transition spd="slow">
+        <p:fade/>
+      </p:transition>
+    </mc:Fallback>
+  </mc:AlternateContent>
 </p:sld>
 </file>
 
@@ -5456,18 +5829,15 @@
           <a:bodyPr wrap="square" lIns="0" tIns="0" rIns="0" bIns="0" rtlCol="0" anchor="ctr"/>
           <a:lstStyle/>
           <a:p>
-            <a:pPr marL="0" indent="0">
-              <a:buNone/>
-            </a:pPr>
             <a:r>
-              <a:rPr lang="en-US" sz="1300" b="1" dirty="0">
+              <a:rPr lang="en-US" sz="1300" b="1">
                 <a:solidFill>
                   <a:srgbClr val="FFFFFF"/>
                 </a:solidFill>
               </a:rPr>
-              <a:t>WEAKNESS 1  |  Geographic Dead Zones</a:t>
+              <a:t>WEAKNESS  1  |  Geographic Dead Zones</a:t>
             </a:r>
-            <a:endParaRPr lang="en-US" sz="1300" dirty="0"/>
+            <a:endParaRPr lang="en-US" sz="1300"/>
           </a:p>
         </p:txBody>
       </p:sp>
@@ -5659,6 +6029,11 @@
         </p:txBody>
       </p:sp>
     </p:spTree>
+    <p:extLst>
+      <p:ext uri="{BB962C8B-B14F-4D97-AF65-F5344CB8AC3E}">
+        <p14:creationId xmlns:p14="http://schemas.microsoft.com/office/powerpoint/2010/main" val="1325269250"/>
+      </p:ext>
+    </p:extLst>
   </p:cSld>
   <p:clrMapOvr>
     <a:masterClrMapping/>
@@ -5737,18 +6112,29 @@
           <a:bodyPr wrap="square" lIns="0" tIns="0" rIns="0" bIns="0" rtlCol="0" anchor="ctr"/>
           <a:lstStyle/>
           <a:p>
-            <a:pPr marL="0" indent="0">
-              <a:buNone/>
-            </a:pPr>
             <a:r>
               <a:rPr lang="en-US" sz="1300" b="1" dirty="0">
                 <a:solidFill>
                   <a:srgbClr val="FFFFFF"/>
                 </a:solidFill>
               </a:rPr>
-              <a:t>WEAKNESS 2  |  Underperforming Store Partners</a:t>
+              <a:t>WEAKNESS 2  | Weak &amp; Inconsistent County Performan</a:t>
             </a:r>
-            <a:endParaRPr lang="en-US" sz="1300" dirty="0"/>
+            <a:r>
+              <a:rPr lang="en-US" sz="1300" b="1">
+                <a:solidFill>
+                  <a:srgbClr val="FFFFFF"/>
+                </a:solidFill>
+              </a:rPr>
+              <a:t>ce</a:t>
+            </a:r>
+            <a:endParaRPr lang="en-US" sz="1300" b="1">
+              <a:solidFill>
+                <a:srgbClr val="FFFFFF"/>
+              </a:solidFill>
+              <a:ea typeface="Calibri"/>
+              <a:cs typeface="Calibri"/>
+            </a:endParaRPr>
           </a:p>
         </p:txBody>
       </p:sp>
@@ -5760,7 +6146,7 @@
         </p:nvSpPr>
         <p:spPr>
           <a:xfrm>
-            <a:off x="457200" y="582519"/>
+            <a:off x="1786" y="506617"/>
             <a:ext cx="8229600" cy="502920"/>
           </a:xfrm>
           <a:prstGeom prst="rect">
@@ -5770,52 +6156,24 @@
           <a:ln/>
         </p:spPr>
         <p:txBody>
-          <a:bodyPr wrap="square" rtlCol="0" anchor="ctr"/>
-          <a:lstStyle/>
-          <a:p>
-            <a:pPr marL="0" indent="0">
-              <a:buNone/>
-            </a:pPr>
+          <a:bodyPr wrap="square" lIns="91440" tIns="45720" rIns="91440" bIns="45720" rtlCol="0" anchor="ctr"/>
+          <a:lstStyle/>
+          <a:p>
             <a:r>
-              <a:rPr lang="en-US" sz="2200" b="1" dirty="0">
+              <a:rPr lang="en-US" sz="2200" b="1">
                 <a:solidFill>
                   <a:srgbClr val="1A1A2E"/>
                 </a:solidFill>
-                <a:latin typeface="Georgia" pitchFamily="34" charset="0"/>
-                <a:ea typeface="Georgia" pitchFamily="34" charset="-122"/>
-                <a:cs typeface="Georgia" pitchFamily="34" charset="-120"/>
+                <a:latin typeface="Georgia"/>
+                <a:ea typeface="+mn-lt"/>
+                <a:cs typeface="+mn-lt"/>
               </a:rPr>
-              <a:t>Underperforming Jim Beam Store Partners</a:t>
+              <a:t>Monthly Revenue Trend: Fremont vs. Polk (2014)</a:t>
             </a:r>
-            <a:endParaRPr lang="en-US" sz="2200" dirty="0"/>
-          </a:p>
-        </p:txBody>
-      </p:sp>
-      <p:pic>
-        <p:nvPicPr>
-          <p:cNvPr id="5" name="Image 0" descr="/home/claude/q6.png"/>
-          <p:cNvPicPr>
-            <a:picLocks noChangeAspect="1"/>
-          </p:cNvPicPr>
-          <p:nvPr/>
-        </p:nvPicPr>
-        <p:blipFill>
-          <a:blip r:embed="rId3"/>
-          <a:srcRect l="-21" t="6619" r="21" b="-6619"/>
-          <a:stretch>
-            <a:fillRect/>
-          </a:stretch>
-        </p:blipFill>
-        <p:spPr>
-          <a:xfrm>
-            <a:off x="211764" y="1087117"/>
-            <a:ext cx="8719209" cy="3964728"/>
-          </a:xfrm>
-          <a:prstGeom prst="rect">
-            <a:avLst/>
-          </a:prstGeom>
-        </p:spPr>
-      </p:pic>
+            <a:endParaRPr lang="en-US"/>
+          </a:p>
+        </p:txBody>
+      </p:sp>
       <p:sp>
         <p:nvSpPr>
           <p:cNvPr id="8" name="Text 5"/>
@@ -5853,11 +6211,53 @@
           </a:p>
         </p:txBody>
       </p:sp>
+      <p:pic>
+        <p:nvPicPr>
+          <p:cNvPr id="7" name="Picture 6" descr="A graph with a line going up&#10;&#10;AI-generated content may be incorrect.">
+            <a:extLst>
+              <a:ext uri="{FF2B5EF4-FFF2-40B4-BE49-F238E27FC236}">
+                <a16:creationId xmlns:a16="http://schemas.microsoft.com/office/drawing/2014/main" id="{3E305FB7-C8BE-BC8F-2D81-724F50C27F83}"/>
+              </a:ext>
+            </a:extLst>
+          </p:cNvPr>
+          <p:cNvPicPr>
+            <a:picLocks noChangeAspect="1"/>
+          </p:cNvPicPr>
+          <p:nvPr/>
+        </p:nvPicPr>
+        <p:blipFill>
+          <a:blip r:embed="rId3"/>
+          <a:stretch>
+            <a:fillRect/>
+          </a:stretch>
+        </p:blipFill>
+        <p:spPr>
+          <a:xfrm>
+            <a:off x="797512" y="897433"/>
+            <a:ext cx="7553442" cy="4121051"/>
+          </a:xfrm>
+          <a:prstGeom prst="rect">
+            <a:avLst/>
+          </a:prstGeom>
+        </p:spPr>
+      </p:pic>
     </p:spTree>
   </p:cSld>
   <p:clrMapOvr>
     <a:masterClrMapping/>
   </p:clrMapOvr>
+  <mc:AlternateContent xmlns:mc="http://schemas.openxmlformats.org/markup-compatibility/2006" xmlns:p14="http://schemas.microsoft.com/office/powerpoint/2010/main">
+    <mc:Choice Requires="p14">
+      <p:transition spd="slow" p14:dur="1250">
+        <p14:switch dir="r"/>
+      </p:transition>
+    </mc:Choice>
+    <mc:Fallback xmlns="">
+      <p:transition spd="slow">
+        <p:fade/>
+      </p:transition>
+    </mc:Fallback>
+  </mc:AlternateContent>
 </p:sld>
 </file>
 
@@ -6087,6 +6487,18 @@
   <p:clrMapOvr>
     <a:masterClrMapping/>
   </p:clrMapOvr>
+  <mc:AlternateContent xmlns:mc="http://schemas.openxmlformats.org/markup-compatibility/2006" xmlns:p14="http://schemas.microsoft.com/office/powerpoint/2010/main">
+    <mc:Choice Requires="p14">
+      <p:transition spd="slow" p14:dur="1250">
+        <p14:switch dir="r"/>
+      </p:transition>
+    </mc:Choice>
+    <mc:Fallback xmlns="">
+      <p:transition spd="slow">
+        <p:fade/>
+      </p:transition>
+    </mc:Fallback>
+  </mc:AlternateContent>
 </p:sld>
 </file>
 
@@ -6245,6 +6657,18 @@
   <p:clrMapOvr>
     <a:masterClrMapping/>
   </p:clrMapOvr>
+  <mc:AlternateContent xmlns:mc="http://schemas.openxmlformats.org/markup-compatibility/2006" xmlns:p14="http://schemas.microsoft.com/office/powerpoint/2010/main">
+    <mc:Choice Requires="p14">
+      <p:transition spd="slow" p14:dur="1250">
+        <p14:switch dir="r"/>
+      </p:transition>
+    </mc:Choice>
+    <mc:Fallback xmlns="">
+      <p:transition spd="slow">
+        <p:fade/>
+      </p:transition>
+    </mc:Fallback>
+  </mc:AlternateContent>
 </p:sld>
 </file>
 

</xml_diff>